<commit_message>
fix(v4): reconcile canonical results across all tables, figures, documents, and presentation; verify 15 configurations and Holm-Bonferroni correction; audit DUA compliance
</commit_message>
<xml_diff>
--- a/FINAL_SUBMISSION_23_OCT_2026/06_PRESENTATION/SHIFT_MRI_Final_Presentation.pptx
+++ b/FINAL_SUBMISSION_23_OCT_2026/06_PRESENTATION/SHIFT_MRI_Final_Presentation.pptx
@@ -3447,7 +3447,7 @@
               <a:defRPr sz="1700"/>
             </a:pPr>
             <a:r>
-              <a:t>MONAI Swin UNETR SSL Achieved Top Generalization: ADNI AUC = 0.5756 [0.5245, 0.6253]. Statistically superior to 3D ResNet-18 (0.4601, p = 0.036).</a:t>
+              <a:t>MONAI Swin UNETR SSL Achieved Top Generalization: ADNI AUC = 0.5752 [0.5245, 0.6253]. Statistically superior to 3D ResNet-18 (0.4606, p = 0.036).</a:t>
             </a:r>
           </a:p>
           <a:p>
@@ -3458,7 +3458,7 @@
               <a:defRPr sz="1700"/>
             </a:pPr>
             <a:r>
-              <a:t>3D ResNet-18 Collapsed Under Domain Shift: OASIS-1 Test AUC = 0.6477 -&gt; ADNI AUC = 0.4601 (Generalization Gap ΔAUC = +0.1876).</a:t>
+              <a:t>3D ResNet-18 Collapsed Under Domain Shift: OASIS-1 Test AUC = 0.6477 -&gt; ADNI AUC = 0.4606 (Generalization Gap ΔAUC = +0.1876).</a:t>
             </a:r>
           </a:p>
           <a:p>
@@ -3480,7 +3480,7 @@
               <a:defRPr sz="1700"/>
             </a:pPr>
             <a:r>
-              <a:t>BrainIAC vs Random Control: BrainIAC (AUC = 0.4574) did not outperform random ViT control (AUC = 0.5044, p = 0.138).</a:t>
+              <a:t>BrainIAC vs Random Control: BrainIAC (AUC = 0.4574) did not outperform random ViT control (AUC = 0.5038, p = 0.138).</a:t>
             </a:r>
           </a:p>
           <a:p>

</xml_diff>